<commit_message>
Make the regex bug reproducible, and correct slide 10 to match
Slide 10 asked for a screenshot of the ranking before and after the
keyword fix, which was not something anyone could produce — the code is
fixed, so there is no 'before' to capture.

scripts/show_regex_bug.py rebuilds the broken matcher from the same tier
table the working one uses and prints both rankings side by side. Nothing
is mutated and it cannot drift from the shipped code.

Running it also showed the slide's numbers had gone stale. The original
discovery was rank 7 to rank 1 under the old weight table; since the
style budget was raised, keyword carries 0.185 rather than 0.222 and the
same fix now moves it to rank 2, behind a Fed decision by 0.008. The
slide and script now quote the keyword factor going 0.00 to 1.00, which
is both the actual defect and reproducible today.

Co-Authored-By: Claude Opus 5 <noreply@anthropic.com>
Claude-Session: https://claude.ai/code/session_017tHbKQr2z4vqora8wxGMui
</commit_message>
<xml_diff>
--- a/docs/deck/SignalDesk_Part2.pptx
+++ b/docs/deck/SignalDesk_Part2.pptx
@@ -2447,7 +2447,7 @@
                 <a:ea typeface="Calibri" pitchFamily="34" charset="-122"/>
                 <a:cs typeface="Calibri" pitchFamily="34" charset="-120"/>
               </a:rPr>
-              <a:t>So a $62 million protocol hack — the biggest story in the set — scored as untiered noise.</a:t>
+              <a:t>So a $62 million protocol hack scored ZERO on the keyword factor — untiered noise.</a:t>
             </a:r>
             <a:endParaRPr lang="en-US" sz="1350" dirty="0"/>
           </a:p>
@@ -2527,24 +2527,24 @@
         </p:nvSpPr>
         <p:spPr>
           <a:xfrm>
-            <a:off x="777240" y="3383280"/>
-            <a:ext cx="2103120" cy="713232"/>
-          </a:xfrm>
-          <a:prstGeom prst="rect">
-            <a:avLst/>
-          </a:prstGeom>
-          <a:noFill/>
-          <a:ln/>
-        </p:spPr>
-        <p:txBody>
-          <a:bodyPr wrap="square" lIns="0" tIns="0" rIns="0" bIns="0" rtlCol="0" anchor="ctr"/>
-          <a:lstStyle/>
-          <a:p>
-            <a:pPr indent="0" marL="0">
-              <a:buNone/>
-            </a:pPr>
-            <a:r>
-              <a:rPr lang="en-US" sz="3800" b="1" dirty="0">
+            <a:off x="731520" y="3419856"/>
+            <a:ext cx="2240280" cy="457200"/>
+          </a:xfrm>
+          <a:prstGeom prst="rect">
+            <a:avLst/>
+          </a:prstGeom>
+          <a:noFill/>
+          <a:ln/>
+        </p:spPr>
+        <p:txBody>
+          <a:bodyPr wrap="square" lIns="0" tIns="0" rIns="0" bIns="0" rtlCol="0" anchor="ctr"/>
+          <a:lstStyle/>
+          <a:p>
+            <a:pPr indent="0" marL="0">
+              <a:buNone/>
+            </a:pPr>
+            <a:r>
+              <a:rPr lang="en-US" sz="1900" b="1" dirty="0">
                 <a:solidFill>
                   <a:srgbClr val="5E7078"/>
                 </a:solidFill>
@@ -2552,9 +2552,9 @@
                 <a:ea typeface="Courier New" pitchFamily="34" charset="-122"/>
                 <a:cs typeface="Courier New" pitchFamily="34" charset="-120"/>
               </a:rPr>
-              <a:t>#7</a:t>
-            </a:r>
-            <a:endParaRPr lang="en-US" sz="3800" dirty="0"/>
+              <a:t>keyword 0.00</a:t>
+            </a:r>
+            <a:endParaRPr lang="en-US" sz="1900" dirty="0"/>
           </a:p>
         </p:txBody>
       </p:sp>
@@ -2566,24 +2566,24 @@
         </p:nvSpPr>
         <p:spPr>
           <a:xfrm>
-            <a:off x="777240" y="4114800"/>
-            <a:ext cx="2103120" cy="292608"/>
-          </a:xfrm>
-          <a:prstGeom prst="rect">
-            <a:avLst/>
-          </a:prstGeom>
-          <a:noFill/>
-          <a:ln/>
-        </p:spPr>
-        <p:txBody>
-          <a:bodyPr wrap="square" lIns="0" tIns="0" rIns="0" bIns="0" rtlCol="0" anchor="ctr"/>
-          <a:lstStyle/>
-          <a:p>
-            <a:pPr indent="0" marL="0">
-              <a:buNone/>
-            </a:pPr>
-            <a:r>
-              <a:rPr lang="en-US" sz="1300" dirty="0">
+            <a:off x="731520" y="3913632"/>
+            <a:ext cx="2240280" cy="457200"/>
+          </a:xfrm>
+          <a:prstGeom prst="rect">
+            <a:avLst/>
+          </a:prstGeom>
+          <a:noFill/>
+          <a:ln/>
+        </p:spPr>
+        <p:txBody>
+          <a:bodyPr wrap="square" lIns="0" tIns="0" rIns="0" bIns="0" rtlCol="0" anchor="ctr"/>
+          <a:lstStyle/>
+          <a:p>
+            <a:pPr indent="0" marL="0">
+              <a:buNone/>
+            </a:pPr>
+            <a:r>
+              <a:rPr lang="en-US" sz="2400" b="1" dirty="0">
                 <a:solidFill>
                   <a:srgbClr val="0E2A31"/>
                 </a:solidFill>
@@ -2591,9 +2591,9 @@
                 <a:ea typeface="Courier New" pitchFamily="34" charset="-122"/>
                 <a:cs typeface="Courier New" pitchFamily="34" charset="-120"/>
               </a:rPr>
-              <a:t>score 0.701</a:t>
-            </a:r>
-            <a:endParaRPr lang="en-US" sz="1300" dirty="0"/>
+              <a:t>rank 7</a:t>
+            </a:r>
+            <a:endParaRPr lang="en-US" sz="2400" dirty="0"/>
           </a:p>
         </p:txBody>
       </p:sp>
@@ -2671,24 +2671,24 @@
         </p:nvSpPr>
         <p:spPr>
           <a:xfrm>
-            <a:off x="3611880" y="3383280"/>
-            <a:ext cx="2103120" cy="713232"/>
-          </a:xfrm>
-          <a:prstGeom prst="rect">
-            <a:avLst/>
-          </a:prstGeom>
-          <a:noFill/>
-          <a:ln/>
-        </p:spPr>
-        <p:txBody>
-          <a:bodyPr wrap="square" lIns="0" tIns="0" rIns="0" bIns="0" rtlCol="0" anchor="ctr"/>
-          <a:lstStyle/>
-          <a:p>
-            <a:pPr indent="0" marL="0">
-              <a:buNone/>
-            </a:pPr>
-            <a:r>
-              <a:rPr lang="en-US" sz="3800" b="1" dirty="0">
+            <a:off x="3566160" y="3419856"/>
+            <a:ext cx="2240280" cy="457200"/>
+          </a:xfrm>
+          <a:prstGeom prst="rect">
+            <a:avLst/>
+          </a:prstGeom>
+          <a:noFill/>
+          <a:ln/>
+        </p:spPr>
+        <p:txBody>
+          <a:bodyPr wrap="square" lIns="0" tIns="0" rIns="0" bIns="0" rtlCol="0" anchor="ctr"/>
+          <a:lstStyle/>
+          <a:p>
+            <a:pPr indent="0" marL="0">
+              <a:buNone/>
+            </a:pPr>
+            <a:r>
+              <a:rPr lang="en-US" sz="1900" b="1" dirty="0">
                 <a:solidFill>
                   <a:srgbClr val="E8963C"/>
                 </a:solidFill>
@@ -2696,9 +2696,9 @@
                 <a:ea typeface="Courier New" pitchFamily="34" charset="-122"/>
                 <a:cs typeface="Courier New" pitchFamily="34" charset="-120"/>
               </a:rPr>
-              <a:t>#1</a:t>
-            </a:r>
-            <a:endParaRPr lang="en-US" sz="3800" dirty="0"/>
+              <a:t>keyword 1.00</a:t>
+            </a:r>
+            <a:endParaRPr lang="en-US" sz="1900" dirty="0"/>
           </a:p>
         </p:txBody>
       </p:sp>
@@ -2710,24 +2710,24 @@
         </p:nvSpPr>
         <p:spPr>
           <a:xfrm>
-            <a:off x="3611880" y="4114800"/>
-            <a:ext cx="2103120" cy="292608"/>
-          </a:xfrm>
-          <a:prstGeom prst="rect">
-            <a:avLst/>
-          </a:prstGeom>
-          <a:noFill/>
-          <a:ln/>
-        </p:spPr>
-        <p:txBody>
-          <a:bodyPr wrap="square" lIns="0" tIns="0" rIns="0" bIns="0" rtlCol="0" anchor="ctr"/>
-          <a:lstStyle/>
-          <a:p>
-            <a:pPr indent="0" marL="0">
-              <a:buNone/>
-            </a:pPr>
-            <a:r>
-              <a:rPr lang="en-US" sz="1300" dirty="0">
+            <a:off x="3566160" y="3913632"/>
+            <a:ext cx="2240280" cy="457200"/>
+          </a:xfrm>
+          <a:prstGeom prst="rect">
+            <a:avLst/>
+          </a:prstGeom>
+          <a:noFill/>
+          <a:ln/>
+        </p:spPr>
+        <p:txBody>
+          <a:bodyPr wrap="square" lIns="0" tIns="0" rIns="0" bIns="0" rtlCol="0" anchor="ctr"/>
+          <a:lstStyle/>
+          <a:p>
+            <a:pPr indent="0" marL="0">
+              <a:buNone/>
+            </a:pPr>
+            <a:r>
+              <a:rPr lang="en-US" sz="2400" b="1" dirty="0">
                 <a:solidFill>
                   <a:srgbClr val="FFFFFF"/>
                 </a:solidFill>
@@ -2735,9 +2735,9 @@
                 <a:ea typeface="Courier New" pitchFamily="34" charset="-122"/>
                 <a:cs typeface="Courier New" pitchFamily="34" charset="-120"/>
               </a:rPr>
-              <a:t>score 0.867</a:t>
-            </a:r>
-            <a:endParaRPr lang="en-US" sz="1300" dirty="0"/>
+              <a:t>rank 2</a:t>
+            </a:r>
+            <a:endParaRPr lang="en-US" sz="2400" dirty="0"/>
           </a:p>
         </p:txBody>
       </p:sp>
@@ -2840,7 +2840,7 @@
                 <a:ea typeface="Courier New" pitchFamily="34" charset="-122"/>
                 <a:cs typeface="Courier New" pitchFamily="34" charset="-120"/>
               </a:rPr>
-              <a:t>Screenshot --once output before and</a:t>
+              <a:t>Run:  python scripts/show_regex_bug.py</a:t>
             </a:r>
             <a:endParaRPr lang="en-US" sz="1150" dirty="0"/>
           </a:p>
@@ -2857,7 +2857,7 @@
                 <a:ea typeface="Courier New" pitchFamily="34" charset="-122"/>
                 <a:cs typeface="Courier New" pitchFamily="34" charset="-120"/>
               </a:rPr>
-              <a:t>after the fix, or the /why table showing</a:t>
+              <a:t>It prints both rankings side by side.</a:t>
             </a:r>
             <a:endParaRPr lang="en-US" sz="1150" dirty="0"/>
           </a:p>
@@ -2874,7 +2874,7 @@
                 <a:ea typeface="Courier New" pitchFamily="34" charset="-122"/>
                 <a:cs typeface="Courier New" pitchFamily="34" charset="-120"/>
               </a:rPr>
-              <a:t>keyword = 1.00 on the exploit story.</a:t>
+              <a:t>One terminal window is the whole slide.</a:t>
             </a:r>
             <a:endParaRPr lang="en-US" sz="1150" dirty="0"/>
           </a:p>

</xml_diff>